<commit_message>
Geschichte 8: Texte im Blocksatz, Zeitstrahl-Blatt zu den Generalständen
Co-Authored-By: Claude Sonnet 5.5 <noreply@anthropic.com>
Claude-Session: https://claude.ai/code/session_01CtRuNVyt8v9M882BKEmgNb
</commit_message>
<xml_diff>
--- a/Geschichte_8/Generalstaende_Stunde1/Praesentation_Generalstaende_Stunde1.pptx
+++ b/Geschichte_8/Generalstaende_Stunde1/Praesentation_Generalstaende_Stunde1.pptx
@@ -506,7 +506,7 @@
           <a:p>
             <a:r>
               <a:rPr lang="en-US" dirty="0"/>
-              <a:t>Ansage: „Ich teile den Text aus. Jetzt arbeitet ihr allein. Die Aufgabe steht rechts.“ Danach Zeitleiste gemeinsam an der Tafel (siehe Tafelskript): 1614 · 1778–1783 · 1787 · 1788 · August 1788 · Frühjahr 1789 · 5. Mai 1789.</a:t>
+              <a:t>Ansage: „Ich teile Text und Zeitstrahl aus. Jetzt arbeitet ihr allein. Die Aufgabe steht rechts.“ Danach Kontrolle an der Tafel (siehe Tafelskript): 1614 · 1778–1783 · 1787 · 1788 · August 1788 · Frühjahr 1789 · 5. Mai 1789. Dann „Vergleicht und verbessert mit Grün.“</a:t>
             </a:r>
             <a:endParaRPr lang="en-US" dirty="0"/>
           </a:p>
@@ -1264,7 +1264,7 @@
                 <a:ea typeface="Calibri" pitchFamily="34" charset="-122"/>
                 <a:cs typeface="Calibri" pitchFamily="34" charset="-120"/>
               </a:rPr>
-              <a:t>ÜBUNG 1 · TEXT</a:t>
+              <a:t>ÜBUNG 1 · TEXT UND ZEITSTRAHL</a:t>
             </a:r>
             <a:endParaRPr lang="en-US" sz="1300" dirty="0"/>
           </a:p>
@@ -1423,7 +1423,7 @@
                 <a:ea typeface="Calibri" pitchFamily="34" charset="-122"/>
                 <a:cs typeface="Calibri" pitchFamily="34" charset="-120"/>
               </a:rPr>
-              <a:t>Lies den Text.</a:t>
+              <a:t>Lies den Text. Unterstreiche die Jahreszahlen.</a:t>
             </a:r>
             <a:endParaRPr lang="en-US" sz="2400" dirty="0"/>
           </a:p>
@@ -1521,7 +1521,7 @@
                 <a:ea typeface="Calibri" pitchFamily="34" charset="-122"/>
                 <a:cs typeface="Calibri" pitchFamily="34" charset="-120"/>
               </a:rPr>
-              <a:t>Unterstreiche alle Jahreszahlen.</a:t>
+              <a:t>Trage die Daten in den Zeitstrahl ein.</a:t>
             </a:r>
             <a:endParaRPr lang="en-US" sz="2400" dirty="0"/>
           </a:p>
@@ -1619,7 +1619,7 @@
                 <a:ea typeface="Calibri" pitchFamily="34" charset="-122"/>
                 <a:cs typeface="Calibri" pitchFamily="34" charset="-120"/>
               </a:rPr>
-              <a:t>Schreibe zu jeder Jahreszahl ein Stichwort.</a:t>
+              <a:t>Prüfe: Passt jedes Datum zum Ereignis?</a:t>
             </a:r>
             <a:endParaRPr lang="en-US" sz="2400" dirty="0"/>
           </a:p>
@@ -1694,7 +1694,7 @@
                 <a:ea typeface="Calibri" pitchFamily="34" charset="-122"/>
                 <a:cs typeface="Calibri" pitchFamily="34" charset="-120"/>
               </a:rPr>
-              <a:t>3 Minuten · allein · leise      </a:t>
+              <a:t>5 Minuten · allein · leise      </a:t>
             </a:r>
             <a:pPr indent="0" marL="0">
               <a:buNone/>

</xml_diff>

<commit_message>
Geschichte 8: Abstimmung erst historisches Beispiel, dann Schulbeispiel
Co-Authored-By: Claude Sonnet 5.5 <noreply@anthropic.com>
Claude-Session: https://claude.ai/code/session_01CtRuNVyt8v9M882BKEmgNb
</commit_message>
<xml_diff>
--- a/Geschichte_8/Generalstaende_Stunde1/Praesentation_Generalstaende_Stunde1.pptx
+++ b/Geschichte_8/Generalstaende_Stunde1/Praesentation_Generalstaende_Stunde1.pptx
@@ -10,9 +10,10 @@
     <p:sldId id="258" r:id="rId4"/>
     <p:sldId id="259" r:id="rId5"/>
     <p:sldId id="260" r:id="rId6"/>
+    <p:sldId id="261" r:id="rId7"/>
   </p:sldIdLst>
   <p:notesMasterIdLst>
-    <p:notesMasterId r:id="rId7"/>
+    <p:notesMasterId r:id="rId8"/>
   </p:notesMasterIdLst>
   <p:sldSz cx="12192000" cy="6858000"/>
   <p:notesSz cx="6858000" cy="12192000"/>
@@ -682,7 +683,7 @@
           <a:p>
             <a:r>
               <a:rPr lang="en-US" dirty="0"/>
-              <a:t>Ansage: „Wir spielen jetzt eine Abstimmung. Das ist nur ein Spiel, es gilt nicht.“ Schritt 1, nach Ständen: Jede Gruppe eine Stimme. Klerus (L1) Ja, Adel (L2) Ja, Dritter Stand (Schüler) Nein: 2:1, angenommen. Schritt 2, nach Köpfen: 2 Ja, 12 Nein: abgelehnt. Fragen: Wie fühlt sich das an? Was ist unfair? Sind die Lehrkräfte das Problem oder die Regeln? Sollbruchstelle: Bei Zeitnot entfällt die Abstimmung und beginnt Stunde 2.</a:t>
+              <a:t>Modellannahme: Klerus und Adel stimmen geschlossen Nein, der Dritte Stand Ja. Nach Ständen: 2:1, abgelehnt. Nach Köpfen: Ja 580, Nein 290 + 270 = 560, knapp angenommen. Hinweis: Die Annahme ist vereinfacht, tatsächlich unterstützten manche Geistliche und einzelne Adlige den Dritten Stand. Frage: Wie wichtig ist die Abstimmungsregel?</a:t>
             </a:r>
             <a:endParaRPr lang="en-US" dirty="0"/>
           </a:p>
@@ -770,7 +771,7 @@
           <a:p>
             <a:r>
               <a:rPr lang="en-US" dirty="0"/>
-              <a:t>Ansage: „Jetzt schreibt ihr von der Folie ab: Merksatz 1. Rahmt ihn rot ein.“ Rechnung dazu an der Tafel: 20 000 000 : 150 000 ≈ 133 (Klerus), 20 000 000 : 500 000 = 40 (Adel).</a:t>
+              <a:t>Ansage: „Jetzt spielen wir dasselbe in der Schule. Das ist nur ein Spiel, es gilt nicht.“ Schritt 1, nach Ständen: Klerus (L1) Ja, Adel (L2) Ja, Dritter Stand (Schüler) Nein: 2:1, angenommen. Schritt 2, nach Köpfen: 2 Ja, 12 Nein: abgelehnt. Fragen: Wie fühlt sich das an? Was ist unfair? Sind die Lehrkräfte das Problem oder die Regeln? Sollbruchstelle: Bei Zeitnot entfällt das Schulbeispiel und beginnt Stunde 2.</a:t>
             </a:r>
             <a:endParaRPr lang="en-US" dirty="0"/>
           </a:p>
@@ -858,7 +859,7 @@
           <a:p>
             <a:r>
               <a:rPr lang="en-US" dirty="0"/>
-              <a:t>Ansage: „Jetzt arbeitet ihr allein. Die Aufgabe steht rechts.“ Beispiel: „… weil der Dritte Stand (Bauern und Bürger) ca. 97 % der Menschen stellt, aber nur eine von drei Stimmen hat und immer überstimmt wird.“ Ausblick: Was passiert, wenn der Dritte Stand nach Köpfen fordert und der König ablehnt? (Stunde 2)</a:t>
+              <a:t>Ansage: „Jetzt schreibt ihr von der Folie ab: Merksatz 1. Rahmt ihn rot ein.“ Rechnung dazu an der Tafel: 20 000 000 : 150 000 ≈ 133 (Klerus), 20 000 000 : 500 000 = 40 (Adel).</a:t>
             </a:r>
             <a:endParaRPr lang="en-US" dirty="0"/>
           </a:p>
@@ -882,6 +883,94 @@
             <a:fld id="{F7021451-1387-4CA6-816F-3879F97B5CBC}" type="slidenum">
               <a:rPr lang="en-US"/>
               <a:t>5</a:t>
+            </a:fld>
+            <a:endParaRPr lang="en-US"/>
+          </a:p>
+        </p:txBody>
+      </p:sp>
+    </p:spTree>
+    <p:extLst>
+      <p:ext uri="{BB962C8B-B14F-4D97-AF65-F5344CB8AC3E}">
+        <p14:creationId xmlns:p14="http://schemas.microsoft.com/office/powerpoint/2010/main" val="1024086991"/>
+      </p:ext>
+    </p:extLst>
+  </p:cSld>
+  <p:clrMapOvr>
+    <a:masterClrMapping/>
+  </p:clrMapOvr>
+</p:notes>
+</file>
+
+<file path=ppt/notesSlides/notesSlide6.xml><?xml version="1.0" encoding="utf-8"?>
+<p:notes xmlns:a="http://schemas.openxmlformats.org/drawingml/2006/main" xmlns:r="http://schemas.openxmlformats.org/officeDocument/2006/relationships" xmlns:p="http://schemas.openxmlformats.org/presentationml/2006/main">
+  <p:cSld>
+    <p:spTree>
+      <p:nvGrpSpPr>
+        <p:cNvPr id="1" name=""/>
+        <p:cNvGrpSpPr/>
+        <p:nvPr/>
+      </p:nvGrpSpPr>
+      <p:grpSpPr>
+        <a:xfrm>
+          <a:off x="0" y="0"/>
+          <a:ext cx="0" cy="0"/>
+          <a:chOff x="0" y="0"/>
+          <a:chExt cx="0" cy="0"/>
+        </a:xfrm>
+      </p:grpSpPr>
+      <p:sp>
+        <p:nvSpPr>
+          <p:cNvPr id="2" name="Slide Image Placeholder 1"/>
+          <p:cNvSpPr>
+            <a:spLocks noGrp="1" noRot="1" noChangeAspect="1"/>
+          </p:cNvSpPr>
+          <p:nvPr>
+            <p:ph type="sldImg"/>
+          </p:nvPr>
+        </p:nvSpPr>
+        <p:spPr/>
+      </p:sp>
+      <p:sp>
+        <p:nvSpPr>
+          <p:cNvPr id="3" name="Notes Placeholder 2"/>
+          <p:cNvSpPr>
+            <a:spLocks noGrp="1"/>
+          </p:cNvSpPr>
+          <p:nvPr>
+            <p:ph type="body" idx="1"/>
+          </p:nvPr>
+        </p:nvSpPr>
+        <p:spPr/>
+        <p:txBody>
+          <a:bodyPr/>
+          <a:lstStyle/>
+          <a:p>
+            <a:r>
+              <a:rPr lang="en-US" dirty="0"/>
+              <a:t>Ansage: „Jetzt arbeitet ihr allein. Die Aufgabe steht rechts.“ Beispiel: „… weil der Dritte Stand (Bauern und Bürger) ca. 97 % der Menschen stellt, aber nur eine von drei Stimmen hat und immer überstimmt wird.“ Ausblick: Was passiert, wenn der Dritte Stand nach Köpfen fordert und der König ablehnt? (Stunde 2)</a:t>
+            </a:r>
+            <a:endParaRPr lang="en-US" dirty="0"/>
+          </a:p>
+        </p:txBody>
+      </p:sp>
+      <p:sp>
+        <p:nvSpPr>
+          <p:cNvPr id="4" name="Slide Number Placeholder 3"/>
+          <p:cNvSpPr>
+            <a:spLocks noGrp="1"/>
+          </p:cNvSpPr>
+          <p:nvPr>
+            <p:ph type="sldNum" sz="quarter" idx="10"/>
+          </p:nvPr>
+        </p:nvSpPr>
+        <p:spPr/>
+        <p:txBody>
+          <a:bodyPr/>
+          <a:lstStyle/>
+          <a:p>
+            <a:fld id="{F7021451-1387-4CA6-816F-3879F97B5CBC}" type="slidenum">
+              <a:rPr lang="en-US"/>
+              <a:t>6</a:t>
             </a:fld>
             <a:endParaRPr lang="en-US"/>
           </a:p>
@@ -3329,7 +3418,7 @@
                 <a:ea typeface="Calibri" pitchFamily="34" charset="-122"/>
                 <a:cs typeface="Calibri" pitchFamily="34" charset="-120"/>
               </a:rPr>
-              <a:t>ABSTIMMUNG · NUR EIN SPIEL</a:t>
+              <a:t>ABSTIMMUNG 1789 · MODELL</a:t>
             </a:r>
             <a:endParaRPr lang="en-US" sz="1300" dirty="0"/>
           </a:p>
@@ -3368,7 +3457,7 @@
                 <a:ea typeface="Cambria" pitchFamily="34" charset="-122"/>
                 <a:cs typeface="Cambria" pitchFamily="34" charset="-120"/>
               </a:rPr>
-              <a:t>Antrag</a:t>
+              <a:t>Antrag in den Generalständen</a:t>
             </a:r>
             <a:endParaRPr lang="en-US" sz="3400" dirty="0"/>
           </a:p>
@@ -3383,11 +3472,11 @@
         <p:spPr>
           <a:xfrm>
             <a:off x="548640" y="1417320"/>
-            <a:ext cx="11109960" cy="2743200"/>
+            <a:ext cx="11109960" cy="2011680"/>
           </a:xfrm>
           <a:prstGeom prst="roundRect">
             <a:avLst>
-              <a:gd name="adj" fmla="val 2667"/>
+              <a:gd name="adj" fmla="val 3636"/>
             </a:avLst>
           </a:prstGeom>
           <a:solidFill>
@@ -3410,7 +3499,7 @@
         <p:spPr>
           <a:xfrm>
             <a:off x="868680" y="1463040"/>
-            <a:ext cx="10469880" cy="2651760"/>
+            <a:ext cx="10469880" cy="1920240"/>
           </a:xfrm>
           <a:prstGeom prst="rect">
             <a:avLst/>
@@ -3426,7 +3515,7 @@
               <a:buNone/>
             </a:pPr>
             <a:r>
-              <a:rPr lang="en-US" sz="3200" b="1" dirty="0">
+              <a:rPr lang="en-US" sz="3400" b="1" dirty="0">
                 <a:solidFill>
                   <a:srgbClr val="1E2761"/>
                 </a:solidFill>
@@ -3434,9 +3523,9 @@
                 <a:ea typeface="Cambria" pitchFamily="34" charset="-122"/>
                 <a:cs typeface="Cambria" pitchFamily="34" charset="-120"/>
               </a:rPr>
-              <a:t>Nur Schüler putzen künftig das Klassenzimmer und räumen die Tische auf. Lehrkräfte sind davon befreit.</a:t>
-            </a:r>
-            <a:endParaRPr lang="en-US" sz="3200" dirty="0"/>
+              <a:t>Auch Adel und Klerus zahlen künftig Steuern.</a:t>
+            </a:r>
+            <a:endParaRPr lang="en-US" sz="3400" dirty="0"/>
           </a:p>
         </p:txBody>
       </p:sp>
@@ -3448,8 +3537,8 @@
         </p:nvSpPr>
         <p:spPr>
           <a:xfrm>
-            <a:off x="548640" y="4389120"/>
-            <a:ext cx="11109960" cy="822960"/>
+            <a:off x="548640" y="3657600"/>
+            <a:ext cx="11109960" cy="1737360"/>
           </a:xfrm>
           <a:prstGeom prst="rect">
             <a:avLst/>
@@ -3473,7 +3562,7 @@
                 <a:ea typeface="Cambria" pitchFamily="34" charset="-122"/>
                 <a:cs typeface="Cambria" pitchFamily="34" charset="-120"/>
               </a:rPr>
-              <a:t>Klerus: Lehrkraft 1 · Adel: Lehrkraft 2 · Dritter Stand (Bauern und Bürger): die Schüler</a:t>
+              <a:t>Klerus und Adel stimmen mit Nein, der Dritte Stand (Bauern und Bürger) mit Ja. Wer gewinnt: nach Ständen? Nach Köpfen?</a:t>
             </a:r>
             <a:endParaRPr lang="en-US" sz="2400" dirty="0"/>
           </a:p>
@@ -3534,7 +3623,7 @@
                 <a:ea typeface="Calibri" pitchFamily="34" charset="-122"/>
                 <a:cs typeface="Calibri" pitchFamily="34" charset="-120"/>
               </a:rPr>
-              <a:t>Hinweis: </a:t>
+              <a:t>Jetzt: </a:t>
             </a:r>
             <a:pPr indent="0" marL="0">
               <a:buNone/>
@@ -3548,7 +3637,7 @@
                 <a:ea typeface="Calibri" pitchFamily="34" charset="-122"/>
                 <a:cs typeface="Calibri" pitchFamily="34" charset="-120"/>
               </a:rPr>
-              <a:t>Das ist nur ein Spiel. Der Antrag gilt nicht.</a:t>
+              <a:t>Meldet euch. Wir rechnen gemeinsam.</a:t>
             </a:r>
             <a:endParaRPr lang="en-US" sz="2400" dirty="0"/>
           </a:p>
@@ -3697,7 +3786,7 @@
                 <a:ea typeface="Calibri" pitchFamily="34" charset="-122"/>
                 <a:cs typeface="Calibri" pitchFamily="34" charset="-120"/>
               </a:rPr>
-              <a:t>MERKSATZ 1 · ABSCHREIBEN UND ROT UMRAHMEN</a:t>
+              <a:t>ABSTIMMUNG · NUR EIN SPIEL</a:t>
             </a:r>
             <a:endParaRPr lang="en-US" sz="1300" dirty="0"/>
           </a:p>
@@ -3736,7 +3825,7 @@
                 <a:ea typeface="Cambria" pitchFamily="34" charset="-122"/>
                 <a:cs typeface="Cambria" pitchFamily="34" charset="-120"/>
               </a:rPr>
-              <a:t>Abstimmung nach Ständen</a:t>
+              <a:t>Antrag in der Schule</a:t>
             </a:r>
             <a:endParaRPr lang="en-US" sz="3400" dirty="0"/>
           </a:p>
@@ -3750,12 +3839,12 @@
         </p:nvSpPr>
         <p:spPr>
           <a:xfrm>
-            <a:off x="548640" y="1371600"/>
-            <a:ext cx="11109960" cy="1920240"/>
+            <a:off x="548640" y="1417320"/>
+            <a:ext cx="11109960" cy="2743200"/>
           </a:xfrm>
           <a:prstGeom prst="roundRect">
             <a:avLst>
-              <a:gd name="adj" fmla="val 3810"/>
+              <a:gd name="adj" fmla="val 2667"/>
             </a:avLst>
           </a:prstGeom>
           <a:solidFill>
@@ -3777,8 +3866,8 @@
         </p:nvSpPr>
         <p:spPr>
           <a:xfrm>
-            <a:off x="868680" y="1417320"/>
-            <a:ext cx="10469880" cy="1828800"/>
+            <a:off x="868680" y="1463040"/>
+            <a:ext cx="10469880" cy="2651760"/>
           </a:xfrm>
           <a:prstGeom prst="rect">
             <a:avLst/>
@@ -3794,7 +3883,7 @@
               <a:buNone/>
             </a:pPr>
             <a:r>
-              <a:rPr lang="en-US" sz="2400" dirty="0">
+              <a:rPr lang="en-US" sz="3200" b="1" dirty="0">
                 <a:solidFill>
                   <a:srgbClr val="1E2761"/>
                 </a:solidFill>
@@ -3802,91 +3891,46 @@
                 <a:ea typeface="Cambria" pitchFamily="34" charset="-122"/>
                 <a:cs typeface="Cambria" pitchFamily="34" charset="-120"/>
               </a:rPr>
-              <a:t>Bei den Generalständen hat jeder Stand </a:t>
-            </a:r>
-            <a:pPr indent="0" marL="0">
-              <a:buNone/>
-            </a:pPr>
-            <a:r>
-              <a:rPr lang="en-US" sz="2400" b="1" dirty="0">
-                <a:solidFill>
-                  <a:srgbClr val="1E2761"/>
+              <a:t>Nur Schüler putzen künftig das Klassenzimmer und räumen die Tische auf. Lehrkräfte sind davon befreit.</a:t>
+            </a:r>
+            <a:endParaRPr lang="en-US" sz="3200" dirty="0"/>
+          </a:p>
+        </p:txBody>
+      </p:sp>
+      <p:sp>
+        <p:nvSpPr>
+          <p:cNvPr id="6" name="Text 4"/>
+          <p:cNvSpPr txBox="1"/>
+          <p:nvPr/>
+        </p:nvSpPr>
+        <p:spPr>
+          <a:xfrm>
+            <a:off x="548640" y="4389120"/>
+            <a:ext cx="11109960" cy="822960"/>
+          </a:xfrm>
+          <a:prstGeom prst="rect">
+            <a:avLst/>
+          </a:prstGeom>
+          <a:noFill/>
+          <a:ln/>
+        </p:spPr>
+        <p:txBody>
+          <a:bodyPr wrap="square" lIns="0" tIns="0" rIns="0" bIns="0" rtlCol="0" anchor="t"/>
+          <a:lstStyle/>
+          <a:p>
+            <a:pPr indent="0" marL="0">
+              <a:buNone/>
+            </a:pPr>
+            <a:r>
+              <a:rPr lang="en-US" sz="2400" dirty="0">
+                <a:solidFill>
+                  <a:srgbClr val="5B6B8C"/>
                 </a:solidFill>
                 <a:latin typeface="Cambria" pitchFamily="34" charset="0"/>
                 <a:ea typeface="Cambria" pitchFamily="34" charset="-122"/>
                 <a:cs typeface="Cambria" pitchFamily="34" charset="-120"/>
               </a:rPr>
-              <a:t>eine Stimme</a:t>
-            </a:r>
-            <a:pPr indent="0" marL="0">
-              <a:buNone/>
-            </a:pPr>
-            <a:r>
-              <a:rPr lang="en-US" sz="2400" dirty="0">
-                <a:solidFill>
-                  <a:srgbClr val="1E2761"/>
-                </a:solidFill>
-                <a:latin typeface="Cambria" pitchFamily="34" charset="0"/>
-                <a:ea typeface="Cambria" pitchFamily="34" charset="-122"/>
-                <a:cs typeface="Cambria" pitchFamily="34" charset="-120"/>
-              </a:rPr>
-              <a:t>. Klerus und Adel (zusammen ca. 3 % der Bevölkerung) haben damit </a:t>
-            </a:r>
-            <a:pPr indent="0" marL="0">
-              <a:buNone/>
-            </a:pPr>
-            <a:r>
-              <a:rPr lang="en-US" sz="2400" b="1" dirty="0">
-                <a:solidFill>
-                  <a:srgbClr val="1E2761"/>
-                </a:solidFill>
-                <a:latin typeface="Cambria" pitchFamily="34" charset="0"/>
-                <a:ea typeface="Cambria" pitchFamily="34" charset="-122"/>
-                <a:cs typeface="Cambria" pitchFamily="34" charset="-120"/>
-              </a:rPr>
-              <a:t>zwei von drei Stimmen</a:t>
-            </a:r>
-            <a:pPr indent="0" marL="0">
-              <a:buNone/>
-            </a:pPr>
-            <a:r>
-              <a:rPr lang="en-US" sz="2400" dirty="0">
-                <a:solidFill>
-                  <a:srgbClr val="1E2761"/>
-                </a:solidFill>
-                <a:latin typeface="Cambria" pitchFamily="34" charset="0"/>
-                <a:ea typeface="Cambria" pitchFamily="34" charset="-122"/>
-                <a:cs typeface="Cambria" pitchFamily="34" charset="-120"/>
-              </a:rPr>
-              <a:t> und können den Dritten Stand (Bauern und Bürger, ca. 97 %) </a:t>
-            </a:r>
-            <a:pPr indent="0" marL="0">
-              <a:buNone/>
-            </a:pPr>
-            <a:r>
-              <a:rPr lang="en-US" sz="2400" b="1" dirty="0">
-                <a:solidFill>
-                  <a:srgbClr val="1E2761"/>
-                </a:solidFill>
-                <a:latin typeface="Cambria" pitchFamily="34" charset="0"/>
-                <a:ea typeface="Cambria" pitchFamily="34" charset="-122"/>
-                <a:cs typeface="Cambria" pitchFamily="34" charset="-120"/>
-              </a:rPr>
-              <a:t>immer überstimmen</a:t>
-            </a:r>
-            <a:pPr indent="0" marL="0">
-              <a:buNone/>
-            </a:pPr>
-            <a:r>
-              <a:rPr lang="en-US" sz="2400" dirty="0">
-                <a:solidFill>
-                  <a:srgbClr val="1E2761"/>
-                </a:solidFill>
-                <a:latin typeface="Cambria" pitchFamily="34" charset="0"/>
-                <a:ea typeface="Cambria" pitchFamily="34" charset="-122"/>
-                <a:cs typeface="Cambria" pitchFamily="34" charset="-120"/>
-              </a:rPr>
-              <a:t>.</a:t>
+              <a:t>Klerus: Lehrkraft 1 · Adel: Lehrkraft 2 · Dritter Stand (Bauern und Bürger): die Schüler</a:t>
             </a:r>
             <a:endParaRPr lang="en-US" sz="2400" dirty="0"/>
           </a:p>
@@ -3894,213 +3938,7 @@
       </p:sp>
       <p:sp>
         <p:nvSpPr>
-          <p:cNvPr id="6" name="Shape 4"/>
-          <p:cNvSpPr/>
-          <p:nvPr/>
-        </p:nvSpPr>
-        <p:spPr>
-          <a:xfrm>
-            <a:off x="548640" y="3401568"/>
-            <a:ext cx="11109960" cy="1143000"/>
-          </a:xfrm>
-          <a:prstGeom prst="roundRect">
-            <a:avLst>
-              <a:gd name="adj" fmla="val 6400"/>
-            </a:avLst>
-          </a:prstGeom>
-          <a:solidFill>
-            <a:srgbClr val="EAF0FA"/>
-          </a:solidFill>
-          <a:ln/>
-        </p:spPr>
-      </p:sp>
-      <p:sp>
-        <p:nvSpPr>
-          <p:cNvPr id="7" name="Text 5"/>
-          <p:cNvSpPr txBox="1"/>
-          <p:nvPr/>
-        </p:nvSpPr>
-        <p:spPr>
-          <a:xfrm>
-            <a:off x="822960" y="3401568"/>
-            <a:ext cx="10607040" cy="1143000"/>
-          </a:xfrm>
-          <a:prstGeom prst="rect">
-            <a:avLst/>
-          </a:prstGeom>
-          <a:noFill/>
-          <a:ln/>
-        </p:spPr>
-        <p:txBody>
-          <a:bodyPr wrap="square" lIns="0" tIns="0" rIns="0" bIns="0" rtlCol="0" anchor="ctr"/>
-          <a:lstStyle/>
-          <a:p>
-            <a:pPr indent="0" marL="0">
-              <a:buNone/>
-            </a:pPr>
-            <a:r>
-              <a:rPr lang="en-US" sz="2400" b="1" dirty="0">
-                <a:solidFill>
-                  <a:srgbClr val="5B6B8C"/>
-                </a:solidFill>
-                <a:latin typeface="Calibri" pitchFamily="34" charset="0"/>
-                <a:ea typeface="Calibri" pitchFamily="34" charset="-122"/>
-                <a:cs typeface="Calibri" pitchFamily="34" charset="-120"/>
-              </a:rPr>
-              <a:t>Beispiel:   </a:t>
-            </a:r>
-            <a:pPr indent="0" marL="0">
-              <a:buNone/>
-            </a:pPr>
-            <a:r>
-              <a:rPr lang="en-US" sz="2400" dirty="0">
-                <a:solidFill>
-                  <a:srgbClr val="1E2761"/>
-                </a:solidFill>
-                <a:latin typeface="Cambria" pitchFamily="34" charset="0"/>
-                <a:ea typeface="Cambria" pitchFamily="34" charset="-122"/>
-                <a:cs typeface="Cambria" pitchFamily="34" charset="-120"/>
-              </a:rPr>
-              <a:t>Eine Stimme des Klerus wiegt rund </a:t>
-            </a:r>
-            <a:pPr indent="0" marL="0">
-              <a:buNone/>
-            </a:pPr>
-            <a:r>
-              <a:rPr lang="en-US" sz="2400" b="1" dirty="0">
-                <a:solidFill>
-                  <a:srgbClr val="1E2761"/>
-                </a:solidFill>
-                <a:latin typeface="Cambria" pitchFamily="34" charset="0"/>
-                <a:ea typeface="Cambria" pitchFamily="34" charset="-122"/>
-                <a:cs typeface="Cambria" pitchFamily="34" charset="-120"/>
-              </a:rPr>
-              <a:t>133-mal</a:t>
-            </a:r>
-            <a:pPr indent="0" marL="0">
-              <a:buNone/>
-            </a:pPr>
-            <a:r>
-              <a:rPr lang="en-US" sz="2400" dirty="0">
-                <a:solidFill>
-                  <a:srgbClr val="1E2761"/>
-                </a:solidFill>
-                <a:latin typeface="Cambria" pitchFamily="34" charset="0"/>
-                <a:ea typeface="Cambria" pitchFamily="34" charset="-122"/>
-                <a:cs typeface="Cambria" pitchFamily="34" charset="-120"/>
-              </a:rPr>
-              <a:t> so viel wie eine des Dritten Standes.</a:t>
-            </a:r>
-            <a:endParaRPr lang="en-US" sz="2400" dirty="0"/>
-          </a:p>
-        </p:txBody>
-      </p:sp>
-      <p:sp>
-        <p:nvSpPr>
-          <p:cNvPr id="8" name="Shape 6"/>
-          <p:cNvSpPr/>
-          <p:nvPr/>
-        </p:nvSpPr>
-        <p:spPr>
-          <a:xfrm>
-            <a:off x="548640" y="4645152"/>
-            <a:ext cx="11109960" cy="886968"/>
-          </a:xfrm>
-          <a:prstGeom prst="roundRect">
-            <a:avLst>
-              <a:gd name="adj" fmla="val 8247"/>
-            </a:avLst>
-          </a:prstGeom>
-          <a:solidFill>
-            <a:srgbClr val="F4F7FD"/>
-          </a:solidFill>
-          <a:ln/>
-        </p:spPr>
-      </p:sp>
-      <p:sp>
-        <p:nvSpPr>
-          <p:cNvPr id="9" name="Text 7"/>
-          <p:cNvSpPr txBox="1"/>
-          <p:nvPr/>
-        </p:nvSpPr>
-        <p:spPr>
-          <a:xfrm>
-            <a:off x="822960" y="4645152"/>
-            <a:ext cx="10607040" cy="886968"/>
-          </a:xfrm>
-          <a:prstGeom prst="rect">
-            <a:avLst/>
-          </a:prstGeom>
-          <a:noFill/>
-          <a:ln/>
-        </p:spPr>
-        <p:txBody>
-          <a:bodyPr wrap="square" lIns="0" tIns="0" rIns="0" bIns="0" rtlCol="0" anchor="ctr"/>
-          <a:lstStyle/>
-          <a:p>
-            <a:pPr indent="0" marL="0">
-              <a:buNone/>
-            </a:pPr>
-            <a:r>
-              <a:rPr lang="en-US" sz="2400" b="1" dirty="0">
-                <a:solidFill>
-                  <a:srgbClr val="D9534F"/>
-                </a:solidFill>
-                <a:latin typeface="Cambria" pitchFamily="34" charset="0"/>
-                <a:ea typeface="Cambria" pitchFamily="34" charset="-122"/>
-                <a:cs typeface="Cambria" pitchFamily="34" charset="-120"/>
-              </a:rPr>
-              <a:t>Test:   </a:t>
-            </a:r>
-            <a:pPr indent="0" marL="0">
-              <a:buNone/>
-            </a:pPr>
-            <a:r>
-              <a:rPr lang="en-US" sz="2400" dirty="0">
-                <a:solidFill>
-                  <a:srgbClr val="1E2761"/>
-                </a:solidFill>
-                <a:latin typeface="Calibri" pitchFamily="34" charset="0"/>
-                <a:ea typeface="Calibri" pitchFamily="34" charset="-122"/>
-                <a:cs typeface="Calibri" pitchFamily="34" charset="-120"/>
-              </a:rPr>
-              <a:t>Wie viele Menschen stehen hinter </a:t>
-            </a:r>
-            <a:pPr indent="0" marL="0">
-              <a:buNone/>
-            </a:pPr>
-            <a:r>
-              <a:rPr lang="en-US" sz="2400" b="1" dirty="0">
-                <a:solidFill>
-                  <a:srgbClr val="1E2761"/>
-                </a:solidFill>
-                <a:latin typeface="Calibri" pitchFamily="34" charset="0"/>
-                <a:ea typeface="Calibri" pitchFamily="34" charset="-122"/>
-                <a:cs typeface="Calibri" pitchFamily="34" charset="-120"/>
-              </a:rPr>
-              <a:t>einer Stimme</a:t>
-            </a:r>
-            <a:pPr indent="0" marL="0">
-              <a:buNone/>
-            </a:pPr>
-            <a:r>
-              <a:rPr lang="en-US" sz="2400" dirty="0">
-                <a:solidFill>
-                  <a:srgbClr val="1E2761"/>
-                </a:solidFill>
-                <a:latin typeface="Calibri" pitchFamily="34" charset="0"/>
-                <a:ea typeface="Calibri" pitchFamily="34" charset="-122"/>
-                <a:cs typeface="Calibri" pitchFamily="34" charset="-120"/>
-              </a:rPr>
-              <a:t>?</a:t>
-            </a:r>
-            <a:endParaRPr lang="en-US" sz="2400" dirty="0"/>
-          </a:p>
-        </p:txBody>
-      </p:sp>
-      <p:sp>
-        <p:nvSpPr>
-          <p:cNvPr id="10" name="Shape 8"/>
+          <p:cNvPr id="7" name="Shape 5"/>
           <p:cNvSpPr/>
           <p:nvPr/>
         </p:nvSpPr>
@@ -4122,7 +3960,7 @@
       </p:sp>
       <p:sp>
         <p:nvSpPr>
-          <p:cNvPr id="11" name="Text 9"/>
+          <p:cNvPr id="8" name="Text 6"/>
           <p:cNvSpPr txBox="1"/>
           <p:nvPr/>
         </p:nvSpPr>
@@ -4153,7 +3991,7 @@
                 <a:ea typeface="Calibri" pitchFamily="34" charset="-122"/>
                 <a:cs typeface="Calibri" pitchFamily="34" charset="-120"/>
               </a:rPr>
-              <a:t>Jetzt: </a:t>
+              <a:t>Hinweis: </a:t>
             </a:r>
             <a:pPr indent="0" marL="0">
               <a:buNone/>
@@ -4167,59 +4005,45 @@
                 <a:ea typeface="Calibri" pitchFamily="34" charset="-122"/>
                 <a:cs typeface="Calibri" pitchFamily="34" charset="-120"/>
               </a:rPr>
-              <a:t>Schreibe den Merksatz mit Beispiel ab und rahme ihn rot ein.      </a:t>
-            </a:r>
-            <a:pPr indent="0" marL="0">
-              <a:buNone/>
-            </a:pPr>
-            <a:r>
-              <a:rPr lang="en-US" sz="2400" i="1" dirty="0">
-                <a:solidFill>
-                  <a:srgbClr val="CADCFC"/>
+              <a:t>Das ist nur ein Spiel. Der Antrag gilt nicht.</a:t>
+            </a:r>
+            <a:endParaRPr lang="en-US" sz="2400" dirty="0"/>
+          </a:p>
+        </p:txBody>
+      </p:sp>
+      <p:sp>
+        <p:nvSpPr>
+          <p:cNvPr id="9" name="Text 7"/>
+          <p:cNvSpPr txBox="1"/>
+          <p:nvPr/>
+        </p:nvSpPr>
+        <p:spPr>
+          <a:xfrm>
+            <a:off x="548640" y="6510528"/>
+            <a:ext cx="5486400" cy="228600"/>
+          </a:xfrm>
+          <a:prstGeom prst="rect">
+            <a:avLst/>
+          </a:prstGeom>
+          <a:noFill/>
+          <a:ln/>
+        </p:spPr>
+        <p:txBody>
+          <a:bodyPr wrap="square" lIns="0" tIns="0" rIns="0" bIns="0" rtlCol="0" anchor="t"/>
+          <a:lstStyle/>
+          <a:p>
+            <a:pPr indent="0" marL="0">
+              <a:buNone/>
+            </a:pPr>
+            <a:r>
+              <a:rPr lang="en-US" sz="1000" dirty="0">
+                <a:solidFill>
+                  <a:srgbClr val="5B6B8C"/>
                 </a:solidFill>
                 <a:latin typeface="Calibri" pitchFamily="34" charset="0"/>
                 <a:ea typeface="Calibri" pitchFamily="34" charset="-122"/>
                 <a:cs typeface="Calibri" pitchFamily="34" charset="-120"/>
               </a:rPr>
-              <a:t>Fertig? Stift hinlegen.</a:t>
-            </a:r>
-            <a:endParaRPr lang="en-US" sz="2400" dirty="0"/>
-          </a:p>
-        </p:txBody>
-      </p:sp>
-      <p:sp>
-        <p:nvSpPr>
-          <p:cNvPr id="12" name="Text 10"/>
-          <p:cNvSpPr txBox="1"/>
-          <p:nvPr/>
-        </p:nvSpPr>
-        <p:spPr>
-          <a:xfrm>
-            <a:off x="548640" y="6510528"/>
-            <a:ext cx="5486400" cy="228600"/>
-          </a:xfrm>
-          <a:prstGeom prst="rect">
-            <a:avLst/>
-          </a:prstGeom>
-          <a:noFill/>
-          <a:ln/>
-        </p:spPr>
-        <p:txBody>
-          <a:bodyPr wrap="square" lIns="0" tIns="0" rIns="0" bIns="0" rtlCol="0" anchor="t"/>
-          <a:lstStyle/>
-          <a:p>
-            <a:pPr indent="0" marL="0">
-              <a:buNone/>
-            </a:pPr>
-            <a:r>
-              <a:rPr lang="en-US" sz="1000" dirty="0">
-                <a:solidFill>
-                  <a:srgbClr val="5B6B8C"/>
-                </a:solidFill>
-                <a:latin typeface="Calibri" pitchFamily="34" charset="0"/>
-                <a:ea typeface="Calibri" pitchFamily="34" charset="-122"/>
-                <a:cs typeface="Calibri" pitchFamily="34" charset="-120"/>
-              </a:rPr>
               <a:t>Generalstände · Geschichte 8</a:t>
             </a:r>
             <a:endParaRPr lang="en-US" sz="1000" dirty="0"/>
@@ -4228,7 +4052,7 @@
       </p:sp>
       <p:sp>
         <p:nvSpPr>
-          <p:cNvPr id="13" name="Text 11"/>
+          <p:cNvPr id="10" name="Text 8"/>
           <p:cNvSpPr txBox="1"/>
           <p:nvPr/>
         </p:nvSpPr>
@@ -4306,6 +4130,639 @@
         <p:spPr>
           <a:xfrm>
             <a:off x="548640" y="320040"/>
+            <a:ext cx="9144000" cy="274320"/>
+          </a:xfrm>
+          <a:prstGeom prst="rect">
+            <a:avLst/>
+          </a:prstGeom>
+          <a:noFill/>
+          <a:ln/>
+        </p:spPr>
+        <p:txBody>
+          <a:bodyPr wrap="square" lIns="0" tIns="0" rIns="0" bIns="0" rtlCol="0" anchor="t"/>
+          <a:lstStyle/>
+          <a:p>
+            <a:pPr indent="0" marL="0">
+              <a:buNone/>
+            </a:pPr>
+            <a:r>
+              <a:rPr lang="en-US" sz="1300" b="1" spc="200" kern="0" dirty="0">
+                <a:solidFill>
+                  <a:srgbClr val="D9534F"/>
+                </a:solidFill>
+                <a:latin typeface="Calibri" pitchFamily="34" charset="0"/>
+                <a:ea typeface="Calibri" pitchFamily="34" charset="-122"/>
+                <a:cs typeface="Calibri" pitchFamily="34" charset="-120"/>
+              </a:rPr>
+              <a:t>MERKSATZ 1 · ABSCHREIBEN UND ROT UMRAHMEN</a:t>
+            </a:r>
+            <a:endParaRPr lang="en-US" sz="1300" dirty="0"/>
+          </a:p>
+        </p:txBody>
+      </p:sp>
+      <p:sp>
+        <p:nvSpPr>
+          <p:cNvPr id="3" name="Text 1"/>
+          <p:cNvSpPr txBox="1"/>
+          <p:nvPr/>
+        </p:nvSpPr>
+        <p:spPr>
+          <a:xfrm>
+            <a:off x="548640" y="594360"/>
+            <a:ext cx="11064240" cy="685800"/>
+          </a:xfrm>
+          <a:prstGeom prst="rect">
+            <a:avLst/>
+          </a:prstGeom>
+          <a:noFill/>
+          <a:ln/>
+        </p:spPr>
+        <p:txBody>
+          <a:bodyPr wrap="square" lIns="0" tIns="0" rIns="0" bIns="0" rtlCol="0" anchor="t"/>
+          <a:lstStyle/>
+          <a:p>
+            <a:pPr indent="0" marL="0">
+              <a:buNone/>
+            </a:pPr>
+            <a:r>
+              <a:rPr lang="en-US" sz="3400" b="1" dirty="0">
+                <a:solidFill>
+                  <a:srgbClr val="1E2761"/>
+                </a:solidFill>
+                <a:latin typeface="Cambria" pitchFamily="34" charset="0"/>
+                <a:ea typeface="Cambria" pitchFamily="34" charset="-122"/>
+                <a:cs typeface="Cambria" pitchFamily="34" charset="-120"/>
+              </a:rPr>
+              <a:t>Abstimmung nach Ständen</a:t>
+            </a:r>
+            <a:endParaRPr lang="en-US" sz="3400" dirty="0"/>
+          </a:p>
+        </p:txBody>
+      </p:sp>
+      <p:sp>
+        <p:nvSpPr>
+          <p:cNvPr id="4" name="Shape 2"/>
+          <p:cNvSpPr/>
+          <p:nvPr/>
+        </p:nvSpPr>
+        <p:spPr>
+          <a:xfrm>
+            <a:off x="548640" y="1371600"/>
+            <a:ext cx="11109960" cy="1920240"/>
+          </a:xfrm>
+          <a:prstGeom prst="roundRect">
+            <a:avLst>
+              <a:gd name="adj" fmla="val 3810"/>
+            </a:avLst>
+          </a:prstGeom>
+          <a:solidFill>
+            <a:srgbClr val="FFFFFF"/>
+          </a:solidFill>
+          <a:ln w="38100">
+            <a:solidFill>
+              <a:srgbClr val="D9534F"/>
+            </a:solidFill>
+            <a:prstDash val="solid"/>
+          </a:ln>
+        </p:spPr>
+      </p:sp>
+      <p:sp>
+        <p:nvSpPr>
+          <p:cNvPr id="5" name="Text 3"/>
+          <p:cNvSpPr txBox="1"/>
+          <p:nvPr/>
+        </p:nvSpPr>
+        <p:spPr>
+          <a:xfrm>
+            <a:off x="868680" y="1417320"/>
+            <a:ext cx="10469880" cy="1828800"/>
+          </a:xfrm>
+          <a:prstGeom prst="rect">
+            <a:avLst/>
+          </a:prstGeom>
+          <a:noFill/>
+          <a:ln/>
+        </p:spPr>
+        <p:txBody>
+          <a:bodyPr wrap="square" lIns="0" tIns="0" rIns="0" bIns="0" rtlCol="0" anchor="ctr"/>
+          <a:lstStyle/>
+          <a:p>
+            <a:pPr indent="0" marL="0">
+              <a:buNone/>
+            </a:pPr>
+            <a:r>
+              <a:rPr lang="en-US" sz="2400" dirty="0">
+                <a:solidFill>
+                  <a:srgbClr val="1E2761"/>
+                </a:solidFill>
+                <a:latin typeface="Cambria" pitchFamily="34" charset="0"/>
+                <a:ea typeface="Cambria" pitchFamily="34" charset="-122"/>
+                <a:cs typeface="Cambria" pitchFamily="34" charset="-120"/>
+              </a:rPr>
+              <a:t>Bei den Generalständen hat jeder Stand </a:t>
+            </a:r>
+            <a:pPr indent="0" marL="0">
+              <a:buNone/>
+            </a:pPr>
+            <a:r>
+              <a:rPr lang="en-US" sz="2400" b="1" dirty="0">
+                <a:solidFill>
+                  <a:srgbClr val="1E2761"/>
+                </a:solidFill>
+                <a:latin typeface="Cambria" pitchFamily="34" charset="0"/>
+                <a:ea typeface="Cambria" pitchFamily="34" charset="-122"/>
+                <a:cs typeface="Cambria" pitchFamily="34" charset="-120"/>
+              </a:rPr>
+              <a:t>eine Stimme</a:t>
+            </a:r>
+            <a:pPr indent="0" marL="0">
+              <a:buNone/>
+            </a:pPr>
+            <a:r>
+              <a:rPr lang="en-US" sz="2400" dirty="0">
+                <a:solidFill>
+                  <a:srgbClr val="1E2761"/>
+                </a:solidFill>
+                <a:latin typeface="Cambria" pitchFamily="34" charset="0"/>
+                <a:ea typeface="Cambria" pitchFamily="34" charset="-122"/>
+                <a:cs typeface="Cambria" pitchFamily="34" charset="-120"/>
+              </a:rPr>
+              <a:t>. Klerus und Adel (zusammen ca. 3 % der Bevölkerung) haben damit </a:t>
+            </a:r>
+            <a:pPr indent="0" marL="0">
+              <a:buNone/>
+            </a:pPr>
+            <a:r>
+              <a:rPr lang="en-US" sz="2400" b="1" dirty="0">
+                <a:solidFill>
+                  <a:srgbClr val="1E2761"/>
+                </a:solidFill>
+                <a:latin typeface="Cambria" pitchFamily="34" charset="0"/>
+                <a:ea typeface="Cambria" pitchFamily="34" charset="-122"/>
+                <a:cs typeface="Cambria" pitchFamily="34" charset="-120"/>
+              </a:rPr>
+              <a:t>zwei von drei Stimmen</a:t>
+            </a:r>
+            <a:pPr indent="0" marL="0">
+              <a:buNone/>
+            </a:pPr>
+            <a:r>
+              <a:rPr lang="en-US" sz="2400" dirty="0">
+                <a:solidFill>
+                  <a:srgbClr val="1E2761"/>
+                </a:solidFill>
+                <a:latin typeface="Cambria" pitchFamily="34" charset="0"/>
+                <a:ea typeface="Cambria" pitchFamily="34" charset="-122"/>
+                <a:cs typeface="Cambria" pitchFamily="34" charset="-120"/>
+              </a:rPr>
+              <a:t> und können den Dritten Stand (Bauern und Bürger, ca. 97 %) </a:t>
+            </a:r>
+            <a:pPr indent="0" marL="0">
+              <a:buNone/>
+            </a:pPr>
+            <a:r>
+              <a:rPr lang="en-US" sz="2400" b="1" dirty="0">
+                <a:solidFill>
+                  <a:srgbClr val="1E2761"/>
+                </a:solidFill>
+                <a:latin typeface="Cambria" pitchFamily="34" charset="0"/>
+                <a:ea typeface="Cambria" pitchFamily="34" charset="-122"/>
+                <a:cs typeface="Cambria" pitchFamily="34" charset="-120"/>
+              </a:rPr>
+              <a:t>immer überstimmen</a:t>
+            </a:r>
+            <a:pPr indent="0" marL="0">
+              <a:buNone/>
+            </a:pPr>
+            <a:r>
+              <a:rPr lang="en-US" sz="2400" dirty="0">
+                <a:solidFill>
+                  <a:srgbClr val="1E2761"/>
+                </a:solidFill>
+                <a:latin typeface="Cambria" pitchFamily="34" charset="0"/>
+                <a:ea typeface="Cambria" pitchFamily="34" charset="-122"/>
+                <a:cs typeface="Cambria" pitchFamily="34" charset="-120"/>
+              </a:rPr>
+              <a:t>.</a:t>
+            </a:r>
+            <a:endParaRPr lang="en-US" sz="2400" dirty="0"/>
+          </a:p>
+        </p:txBody>
+      </p:sp>
+      <p:sp>
+        <p:nvSpPr>
+          <p:cNvPr id="6" name="Shape 4"/>
+          <p:cNvSpPr/>
+          <p:nvPr/>
+        </p:nvSpPr>
+        <p:spPr>
+          <a:xfrm>
+            <a:off x="548640" y="3401568"/>
+            <a:ext cx="11109960" cy="1143000"/>
+          </a:xfrm>
+          <a:prstGeom prst="roundRect">
+            <a:avLst>
+              <a:gd name="adj" fmla="val 6400"/>
+            </a:avLst>
+          </a:prstGeom>
+          <a:solidFill>
+            <a:srgbClr val="EAF0FA"/>
+          </a:solidFill>
+          <a:ln/>
+        </p:spPr>
+      </p:sp>
+      <p:sp>
+        <p:nvSpPr>
+          <p:cNvPr id="7" name="Text 5"/>
+          <p:cNvSpPr txBox="1"/>
+          <p:nvPr/>
+        </p:nvSpPr>
+        <p:spPr>
+          <a:xfrm>
+            <a:off x="822960" y="3401568"/>
+            <a:ext cx="10607040" cy="1143000"/>
+          </a:xfrm>
+          <a:prstGeom prst="rect">
+            <a:avLst/>
+          </a:prstGeom>
+          <a:noFill/>
+          <a:ln/>
+        </p:spPr>
+        <p:txBody>
+          <a:bodyPr wrap="square" lIns="0" tIns="0" rIns="0" bIns="0" rtlCol="0" anchor="ctr"/>
+          <a:lstStyle/>
+          <a:p>
+            <a:pPr indent="0" marL="0">
+              <a:buNone/>
+            </a:pPr>
+            <a:r>
+              <a:rPr lang="en-US" sz="2400" b="1" dirty="0">
+                <a:solidFill>
+                  <a:srgbClr val="5B6B8C"/>
+                </a:solidFill>
+                <a:latin typeface="Calibri" pitchFamily="34" charset="0"/>
+                <a:ea typeface="Calibri" pitchFamily="34" charset="-122"/>
+                <a:cs typeface="Calibri" pitchFamily="34" charset="-120"/>
+              </a:rPr>
+              <a:t>Beispiel:   </a:t>
+            </a:r>
+            <a:pPr indent="0" marL="0">
+              <a:buNone/>
+            </a:pPr>
+            <a:r>
+              <a:rPr lang="en-US" sz="2400" dirty="0">
+                <a:solidFill>
+                  <a:srgbClr val="1E2761"/>
+                </a:solidFill>
+                <a:latin typeface="Cambria" pitchFamily="34" charset="0"/>
+                <a:ea typeface="Cambria" pitchFamily="34" charset="-122"/>
+                <a:cs typeface="Cambria" pitchFamily="34" charset="-120"/>
+              </a:rPr>
+              <a:t>Eine Stimme des Klerus wiegt rund </a:t>
+            </a:r>
+            <a:pPr indent="0" marL="0">
+              <a:buNone/>
+            </a:pPr>
+            <a:r>
+              <a:rPr lang="en-US" sz="2400" b="1" dirty="0">
+                <a:solidFill>
+                  <a:srgbClr val="1E2761"/>
+                </a:solidFill>
+                <a:latin typeface="Cambria" pitchFamily="34" charset="0"/>
+                <a:ea typeface="Cambria" pitchFamily="34" charset="-122"/>
+                <a:cs typeface="Cambria" pitchFamily="34" charset="-120"/>
+              </a:rPr>
+              <a:t>133-mal</a:t>
+            </a:r>
+            <a:pPr indent="0" marL="0">
+              <a:buNone/>
+            </a:pPr>
+            <a:r>
+              <a:rPr lang="en-US" sz="2400" dirty="0">
+                <a:solidFill>
+                  <a:srgbClr val="1E2761"/>
+                </a:solidFill>
+                <a:latin typeface="Cambria" pitchFamily="34" charset="0"/>
+                <a:ea typeface="Cambria" pitchFamily="34" charset="-122"/>
+                <a:cs typeface="Cambria" pitchFamily="34" charset="-120"/>
+              </a:rPr>
+              <a:t> so viel wie eine des Dritten Standes.</a:t>
+            </a:r>
+            <a:endParaRPr lang="en-US" sz="2400" dirty="0"/>
+          </a:p>
+        </p:txBody>
+      </p:sp>
+      <p:sp>
+        <p:nvSpPr>
+          <p:cNvPr id="8" name="Shape 6"/>
+          <p:cNvSpPr/>
+          <p:nvPr/>
+        </p:nvSpPr>
+        <p:spPr>
+          <a:xfrm>
+            <a:off x="548640" y="4645152"/>
+            <a:ext cx="11109960" cy="886968"/>
+          </a:xfrm>
+          <a:prstGeom prst="roundRect">
+            <a:avLst>
+              <a:gd name="adj" fmla="val 8247"/>
+            </a:avLst>
+          </a:prstGeom>
+          <a:solidFill>
+            <a:srgbClr val="F4F7FD"/>
+          </a:solidFill>
+          <a:ln/>
+        </p:spPr>
+      </p:sp>
+      <p:sp>
+        <p:nvSpPr>
+          <p:cNvPr id="9" name="Text 7"/>
+          <p:cNvSpPr txBox="1"/>
+          <p:nvPr/>
+        </p:nvSpPr>
+        <p:spPr>
+          <a:xfrm>
+            <a:off x="822960" y="4645152"/>
+            <a:ext cx="10607040" cy="886968"/>
+          </a:xfrm>
+          <a:prstGeom prst="rect">
+            <a:avLst/>
+          </a:prstGeom>
+          <a:noFill/>
+          <a:ln/>
+        </p:spPr>
+        <p:txBody>
+          <a:bodyPr wrap="square" lIns="0" tIns="0" rIns="0" bIns="0" rtlCol="0" anchor="ctr"/>
+          <a:lstStyle/>
+          <a:p>
+            <a:pPr indent="0" marL="0">
+              <a:buNone/>
+            </a:pPr>
+            <a:r>
+              <a:rPr lang="en-US" sz="2400" b="1" dirty="0">
+                <a:solidFill>
+                  <a:srgbClr val="D9534F"/>
+                </a:solidFill>
+                <a:latin typeface="Cambria" pitchFamily="34" charset="0"/>
+                <a:ea typeface="Cambria" pitchFamily="34" charset="-122"/>
+                <a:cs typeface="Cambria" pitchFamily="34" charset="-120"/>
+              </a:rPr>
+              <a:t>Test:   </a:t>
+            </a:r>
+            <a:pPr indent="0" marL="0">
+              <a:buNone/>
+            </a:pPr>
+            <a:r>
+              <a:rPr lang="en-US" sz="2400" dirty="0">
+                <a:solidFill>
+                  <a:srgbClr val="1E2761"/>
+                </a:solidFill>
+                <a:latin typeface="Calibri" pitchFamily="34" charset="0"/>
+                <a:ea typeface="Calibri" pitchFamily="34" charset="-122"/>
+                <a:cs typeface="Calibri" pitchFamily="34" charset="-120"/>
+              </a:rPr>
+              <a:t>Wie viele Menschen stehen hinter </a:t>
+            </a:r>
+            <a:pPr indent="0" marL="0">
+              <a:buNone/>
+            </a:pPr>
+            <a:r>
+              <a:rPr lang="en-US" sz="2400" b="1" dirty="0">
+                <a:solidFill>
+                  <a:srgbClr val="1E2761"/>
+                </a:solidFill>
+                <a:latin typeface="Calibri" pitchFamily="34" charset="0"/>
+                <a:ea typeface="Calibri" pitchFamily="34" charset="-122"/>
+                <a:cs typeface="Calibri" pitchFamily="34" charset="-120"/>
+              </a:rPr>
+              <a:t>einer Stimme</a:t>
+            </a:r>
+            <a:pPr indent="0" marL="0">
+              <a:buNone/>
+            </a:pPr>
+            <a:r>
+              <a:rPr lang="en-US" sz="2400" dirty="0">
+                <a:solidFill>
+                  <a:srgbClr val="1E2761"/>
+                </a:solidFill>
+                <a:latin typeface="Calibri" pitchFamily="34" charset="0"/>
+                <a:ea typeface="Calibri" pitchFamily="34" charset="-122"/>
+                <a:cs typeface="Calibri" pitchFamily="34" charset="-120"/>
+              </a:rPr>
+              <a:t>?</a:t>
+            </a:r>
+            <a:endParaRPr lang="en-US" sz="2400" dirty="0"/>
+          </a:p>
+        </p:txBody>
+      </p:sp>
+      <p:sp>
+        <p:nvSpPr>
+          <p:cNvPr id="10" name="Shape 8"/>
+          <p:cNvSpPr/>
+          <p:nvPr/>
+        </p:nvSpPr>
+        <p:spPr>
+          <a:xfrm>
+            <a:off x="548640" y="5669280"/>
+            <a:ext cx="11109960" cy="777240"/>
+          </a:xfrm>
+          <a:prstGeom prst="roundRect">
+            <a:avLst>
+              <a:gd name="adj" fmla="val 9412"/>
+            </a:avLst>
+          </a:prstGeom>
+          <a:solidFill>
+            <a:srgbClr val="1E2761"/>
+          </a:solidFill>
+          <a:ln/>
+        </p:spPr>
+      </p:sp>
+      <p:sp>
+        <p:nvSpPr>
+          <p:cNvPr id="11" name="Text 9"/>
+          <p:cNvSpPr txBox="1"/>
+          <p:nvPr/>
+        </p:nvSpPr>
+        <p:spPr>
+          <a:xfrm>
+            <a:off x="822960" y="5669280"/>
+            <a:ext cx="10607040" cy="777240"/>
+          </a:xfrm>
+          <a:prstGeom prst="rect">
+            <a:avLst/>
+          </a:prstGeom>
+          <a:noFill/>
+          <a:ln/>
+        </p:spPr>
+        <p:txBody>
+          <a:bodyPr wrap="square" lIns="0" tIns="0" rIns="0" bIns="0" rtlCol="0" anchor="ctr"/>
+          <a:lstStyle/>
+          <a:p>
+            <a:pPr indent="0" marL="0">
+              <a:buNone/>
+            </a:pPr>
+            <a:r>
+              <a:rPr lang="en-US" sz="2400" b="1" dirty="0">
+                <a:solidFill>
+                  <a:srgbClr val="FFFFFF"/>
+                </a:solidFill>
+                <a:latin typeface="Calibri" pitchFamily="34" charset="0"/>
+                <a:ea typeface="Calibri" pitchFamily="34" charset="-122"/>
+                <a:cs typeface="Calibri" pitchFamily="34" charset="-120"/>
+              </a:rPr>
+              <a:t>Jetzt: </a:t>
+            </a:r>
+            <a:pPr indent="0" marL="0">
+              <a:buNone/>
+            </a:pPr>
+            <a:r>
+              <a:rPr lang="en-US" sz="2400" dirty="0">
+                <a:solidFill>
+                  <a:srgbClr val="FFFFFF"/>
+                </a:solidFill>
+                <a:latin typeface="Calibri" pitchFamily="34" charset="0"/>
+                <a:ea typeface="Calibri" pitchFamily="34" charset="-122"/>
+                <a:cs typeface="Calibri" pitchFamily="34" charset="-120"/>
+              </a:rPr>
+              <a:t>Schreibe den Merksatz mit Beispiel ab und rahme ihn rot ein.      </a:t>
+            </a:r>
+            <a:pPr indent="0" marL="0">
+              <a:buNone/>
+            </a:pPr>
+            <a:r>
+              <a:rPr lang="en-US" sz="2400" i="1" dirty="0">
+                <a:solidFill>
+                  <a:srgbClr val="CADCFC"/>
+                </a:solidFill>
+                <a:latin typeface="Calibri" pitchFamily="34" charset="0"/>
+                <a:ea typeface="Calibri" pitchFamily="34" charset="-122"/>
+                <a:cs typeface="Calibri" pitchFamily="34" charset="-120"/>
+              </a:rPr>
+              <a:t>Fertig? Stift hinlegen.</a:t>
+            </a:r>
+            <a:endParaRPr lang="en-US" sz="2400" dirty="0"/>
+          </a:p>
+        </p:txBody>
+      </p:sp>
+      <p:sp>
+        <p:nvSpPr>
+          <p:cNvPr id="12" name="Text 10"/>
+          <p:cNvSpPr txBox="1"/>
+          <p:nvPr/>
+        </p:nvSpPr>
+        <p:spPr>
+          <a:xfrm>
+            <a:off x="548640" y="6510528"/>
+            <a:ext cx="5486400" cy="228600"/>
+          </a:xfrm>
+          <a:prstGeom prst="rect">
+            <a:avLst/>
+          </a:prstGeom>
+          <a:noFill/>
+          <a:ln/>
+        </p:spPr>
+        <p:txBody>
+          <a:bodyPr wrap="square" lIns="0" tIns="0" rIns="0" bIns="0" rtlCol="0" anchor="t"/>
+          <a:lstStyle/>
+          <a:p>
+            <a:pPr indent="0" marL="0">
+              <a:buNone/>
+            </a:pPr>
+            <a:r>
+              <a:rPr lang="en-US" sz="1000" dirty="0">
+                <a:solidFill>
+                  <a:srgbClr val="5B6B8C"/>
+                </a:solidFill>
+                <a:latin typeface="Calibri" pitchFamily="34" charset="0"/>
+                <a:ea typeface="Calibri" pitchFamily="34" charset="-122"/>
+                <a:cs typeface="Calibri" pitchFamily="34" charset="-120"/>
+              </a:rPr>
+              <a:t>Generalstände · Geschichte 8</a:t>
+            </a:r>
+            <a:endParaRPr lang="en-US" sz="1000" dirty="0"/>
+          </a:p>
+        </p:txBody>
+      </p:sp>
+      <p:sp>
+        <p:nvSpPr>
+          <p:cNvPr id="13" name="Text 11"/>
+          <p:cNvSpPr txBox="1"/>
+          <p:nvPr/>
+        </p:nvSpPr>
+        <p:spPr>
+          <a:xfrm>
+            <a:off x="11155680" y="6510528"/>
+            <a:ext cx="457200" cy="228600"/>
+          </a:xfrm>
+          <a:prstGeom prst="rect">
+            <a:avLst/>
+          </a:prstGeom>
+          <a:noFill/>
+          <a:ln/>
+        </p:spPr>
+        <p:txBody>
+          <a:bodyPr wrap="square" lIns="0" tIns="0" rIns="0" bIns="0" rtlCol="0" anchor="t"/>
+          <a:lstStyle/>
+          <a:p>
+            <a:pPr algn="r" indent="0" marL="0">
+              <a:buNone/>
+            </a:pPr>
+            <a:r>
+              <a:rPr lang="en-US" sz="1000" dirty="0">
+                <a:solidFill>
+                  <a:srgbClr val="5B6B8C"/>
+                </a:solidFill>
+                <a:latin typeface="Calibri" pitchFamily="34" charset="0"/>
+                <a:ea typeface="Calibri" pitchFamily="34" charset="-122"/>
+                <a:cs typeface="Calibri" pitchFamily="34" charset="-120"/>
+              </a:rPr>
+              <a:t>6</a:t>
+            </a:r>
+            <a:endParaRPr lang="en-US" sz="1000" dirty="0"/>
+          </a:p>
+        </p:txBody>
+      </p:sp>
+    </p:spTree>
+  </p:cSld>
+  <p:clrMapOvr>
+    <a:masterClrMapping/>
+  </p:clrMapOvr>
+</p:sld>
+</file>
+
+<file path=ppt/slides/slide6.xml><?xml version="1.0" encoding="utf-8"?>
+<p:sld xmlns:a="http://schemas.openxmlformats.org/drawingml/2006/main" xmlns:r="http://schemas.openxmlformats.org/officeDocument/2006/relationships" xmlns:p="http://schemas.openxmlformats.org/presentationml/2006/main">
+  <p:cSld name="Slide 6">
+    <p:bg>
+      <p:bgPr>
+        <a:solidFill>
+          <a:srgbClr val="FFFFFF"/>
+        </a:solidFill>
+      </p:bgPr>
+    </p:bg>
+    <p:spTree>
+      <p:nvGrpSpPr>
+        <p:cNvPr id="1" name=""/>
+        <p:cNvGrpSpPr/>
+        <p:nvPr/>
+      </p:nvGrpSpPr>
+      <p:grpSpPr>
+        <a:xfrm>
+          <a:off x="0" y="0"/>
+          <a:ext cx="0" cy="0"/>
+          <a:chOff x="0" y="0"/>
+          <a:chExt cx="0" cy="0"/>
+        </a:xfrm>
+      </p:grpSpPr>
+      <p:sp>
+        <p:nvSpPr>
+          <p:cNvPr id="2" name="Text 0"/>
+          <p:cNvSpPr txBox="1"/>
+          <p:nvPr/>
+        </p:nvSpPr>
+        <p:spPr>
+          <a:xfrm>
+            <a:off x="548640" y="320040"/>
             <a:ext cx="7315200" cy="274320"/>
           </a:xfrm>
           <a:prstGeom prst="rect">
@@ -4852,7 +5309,7 @@
                 <a:ea typeface="Calibri" pitchFamily="34" charset="-122"/>
                 <a:cs typeface="Calibri" pitchFamily="34" charset="-120"/>
               </a:rPr>
-              <a:t>6</a:t>
+              <a:t>7</a:t>
             </a:r>
             <a:endParaRPr lang="en-US" sz="1000" dirty="0"/>
           </a:p>

</xml_diff>

<commit_message>
Geschichte 8: Abstimmung 1789 als Gedankenspiel kennzeichnen (nicht nach Köpfen abgestimmt)
Co-Authored-By: Claude Sonnet 5.5 <noreply@anthropic.com>
Claude-Session: https://claude.ai/code/session_01CtRuNVyt8v9M882BKEmgNb
</commit_message>
<xml_diff>
--- a/Geschichte_8/Generalstaende_Stunde1/Praesentation_Generalstaende_Stunde1.pptx
+++ b/Geschichte_8/Generalstaende_Stunde1/Praesentation_Generalstaende_Stunde1.pptx
@@ -605,7 +605,7 @@
           <a:p>
             <a:r>
               <a:rPr lang="en-US" dirty="0"/>
-              <a:t>Nach Ständen: 2:1, abgelehnt. Nach Köpfen: Ja 580, Nein 290 + 270 = 560, knapp angenommen. Kernaussage: Dieselben Stimmen führen je nach Regel zu zwei verschiedenen Ergebnissen. Frage: Wie wichtig ist die Abstimmungsregel für den Dritten Stand (Bauern und Bürger)?</a:t>
+              <a:t>Gedankenspiel, keine historische Abstimmung. Nach Ständen wäre der Antrag 2:1 abgelehnt worden, nach Köpfen mit Ja 580 gegen Nein 290 + 270 = 560 knapp angenommen. Tatsächlich wurde 1789 nicht nach Köpfen abgestimmt: Adel und Klerus bestanden auf der Abstimmung nach Ständen, der Dritte Stand (Bauern und Bürger) forderte die Abstimmung nach Köpfen. Der Streit darum blockierte die Generalstände und führte zur Nationalversammlung (Stunde nach den Ferien). Kernaussage: Dieselben Stimmen führen je nach Regel zu zwei verschiedenen Ergebnissen. Frage: Wie wichtig ist die Abstimmungsregel für den Dritten Stand (Bauern und Bürger)?</a:t>
             </a:r>
             <a:endParaRPr lang="en-US" dirty="0"/>
           </a:p>
@@ -1837,7 +1837,7 @@
           <a:p>
             <a:r>
               <a:rPr lang="en-US" dirty="0"/>
-              <a:t>Modellannahme: Klerus und Adel stimmen geschlossen Nein, der Dritte Stand Ja. Die Klasse rechnet: nach Ständen und nach Köpfen. Ergebnis erst auf Folie 10 zeigen. Hinweis: Die Annahme ist vereinfacht, tatsächlich unterstützten manche Geistliche und einzelne Adlige den Dritten Stand.</a:t>
+              <a:t>WICHTIG: Nach Köpfen wurde 1789 nicht abgestimmt. Das ist ein Gedankenspiel (Modell). Modellannahme: Klerus und Adel stimmen geschlossen Nein, der Dritte Stand Ja. Die Klasse rechnet: nach Ständen und nach Köpfen. Ergebnis erst auf Folie 10 zeigen. Hinweis: Die Annahme ist vereinfacht, tatsächlich unterstützten manche Geistliche und einzelne Adlige den Dritten Stand.</a:t>
             </a:r>
             <a:endParaRPr lang="en-US" dirty="0"/>
           </a:p>
@@ -2432,7 +2432,7 @@
                 <a:ea typeface="Calibri" pitchFamily="34" charset="-122"/>
                 <a:cs typeface="Calibri" pitchFamily="34" charset="-120"/>
               </a:rPr>
-              <a:t>V · VERARBEITEN · ERGEBNIS</a:t>
+              <a:t>V · VERARBEITEN · ERGEBNIS DES GEDANKENSPIELS</a:t>
             </a:r>
             <a:endParaRPr lang="en-US" sz="1300" dirty="0"/>
           </a:p>
@@ -2766,7 +2766,7 @@
                 <a:ea typeface="Cambria" pitchFamily="34" charset="-122"/>
                 <a:cs typeface="Cambria" pitchFamily="34" charset="-120"/>
               </a:rPr>
-              <a:t>Zwei Regeln, zwei Ergebnisse</a:t>
+              <a:t>Zwei Regeln, zwei mögliche Ergebnisse</a:t>
             </a:r>
             <a:endParaRPr lang="en-US" sz="3400" dirty="0"/>
           </a:p>
@@ -3632,7 +3632,7 @@
                 <a:ea typeface="Calibri" pitchFamily="34" charset="-122"/>
                 <a:cs typeface="Calibri" pitchFamily="34" charset="-120"/>
               </a:rPr>
-              <a:t>Merke: </a:t>
+              <a:t>Tatsächlich: </a:t>
             </a:r>
             <a:pPr indent="0" marL="0">
               <a:buNone/>
@@ -3646,7 +3646,7 @@
                 <a:ea typeface="Calibri" pitchFamily="34" charset="-122"/>
                 <a:cs typeface="Calibri" pitchFamily="34" charset="-120"/>
               </a:rPr>
-              <a:t>Die Regel entscheidet, nicht die Mehrheit der Menschen.</a:t>
+              <a:t>Es wurde nicht nach Köpfen abgestimmt. Der Streit um die Regel begann.</a:t>
             </a:r>
             <a:endParaRPr lang="en-US" sz="2400" dirty="0"/>
           </a:p>
@@ -17105,7 +17105,7 @@
                 <a:ea typeface="Calibri" pitchFamily="34" charset="-122"/>
                 <a:cs typeface="Calibri" pitchFamily="34" charset="-120"/>
               </a:rPr>
-              <a:t>V · VERARBEITEN · HISTORISCHES BEISPIEL</a:t>
+              <a:t>V · VERARBEITEN · GEDANKENSPIEL 1789</a:t>
             </a:r>
             <a:endParaRPr lang="en-US" sz="1300" dirty="0"/>
           </a:p>
@@ -17439,7 +17439,7 @@
                 <a:ea typeface="Cambria" pitchFamily="34" charset="-122"/>
                 <a:cs typeface="Cambria" pitchFamily="34" charset="-120"/>
               </a:rPr>
-              <a:t>Antrag in den Generalständen</a:t>
+              <a:t>Was wäre, wenn man abgestimmt hätte?</a:t>
             </a:r>
             <a:endParaRPr lang="en-US" sz="3400" dirty="0"/>
           </a:p>
@@ -18018,7 +18018,7 @@
                 <a:ea typeface="Calibri" pitchFamily="34" charset="-122"/>
                 <a:cs typeface="Calibri" pitchFamily="34" charset="-120"/>
               </a:rPr>
-              <a:t>Wer gewinnt nach Ständen? Wer gewinnt nach Köpfen?</a:t>
+              <a:t>Wer hätte gewonnen: nach Ständen? Nach Köpfen?</a:t>
             </a:r>
             <a:endParaRPr lang="en-US" sz="2400" dirty="0"/>
           </a:p>

</xml_diff>

<commit_message>
Geschichte 8: Zeitstrahl umgekehrt (Daten vorgegeben, Ereignisse ergänzen)
Co-Authored-By: Claude Sonnet 5.5 <noreply@anthropic.com>
Claude-Session: https://claude.ai/code/session_01CtRuNVyt8v9M882BKEmgNb
</commit_message>
<xml_diff>
--- a/Geschichte_8/Generalstaende_Stunde1/Praesentation_Generalstaende_Stunde1.pptx
+++ b/Geschichte_8/Generalstaende_Stunde1/Praesentation_Generalstaende_Stunde1.pptx
@@ -1573,7 +1573,7 @@
           <a:p>
             <a:r>
               <a:rPr lang="en-US" dirty="0"/>
-              <a:t>Ansage: „Ich teile das Blatt aus. Jetzt arbeitet ihr allein. Die Aufgabe steht rechts.“ Oben der Text, unten der Zeitstrahl mit leeren Datenfeldern. Danach Kontrolle (Folie 7): „Wer drankommt, schreibt an die Tafel. Alle prüfen mit.“ Dann „Vergleicht und verbessert mit Grün.“</a:t>
+              <a:t>Ansage: „Ich teile das Blatt aus. Jetzt arbeitet ihr allein. Die Aufgabe steht rechts.“ Oben der Text, unten der Zeitstrahl mit vorgegebenen Daten und leeren Ereignisfeldern. Danach Kontrolle (Folie 7): „Wer drankommt, schreibt an die Tafel. Alle prüfen mit.“ Dann „Vergleicht und verbessert mit Grün.“</a:t>
             </a:r>
             <a:endParaRPr lang="en-US" dirty="0"/>
           </a:p>
@@ -1661,7 +1661,7 @@
           <a:p>
             <a:r>
               <a:rPr lang="en-US" dirty="0"/>
-              <a:t>Erst zeigen, wenn die Klasse die Daten genannt hat („Wer drankommt, schreibt an die Tafel. Alle prüfen mit.“). Dann „Vergleicht und verbessert mit Grün.“ Leitfrage: Warum ruft der König die Generalstände ein, obwohl er sie 175 Jahre nicht brauchte? Antwort: Geldnot, Reformen scheitern, Krise (Hunger, drohender Bankrott). Der Zeitstrahl ist nicht maßstabsgetreu.</a:t>
+              <a:t>Erst zeigen, wenn die Klasse die Ereignisse genannt hat („Wer drankommt, schreibt an die Tafel. Alle prüfen mit.“). Dann „Vergleicht und verbessert mit Grün.“ Leitfrage: Warum ruft der König die Generalstände ein, obwohl er sie 175 Jahre nicht brauchte? Antwort: Geldnot, Reformen scheitern, Krise (Hunger, drohender Bankrott). Der Zeitstrahl ist nicht maßstabsgetreu.</a:t>
             </a:r>
             <a:endParaRPr lang="en-US" dirty="0"/>
           </a:p>
@@ -13507,7 +13507,7 @@
                 <a:ea typeface="Calibri" pitchFamily="34" charset="-122"/>
                 <a:cs typeface="Calibri" pitchFamily="34" charset="-120"/>
               </a:rPr>
-              <a:t>Trage die Daten in den Zeitstrahl ein.</a:t>
+              <a:t>Schreibe zu jedem Datum das Ereignis in den Zeitstrahl.</a:t>
             </a:r>
             <a:endParaRPr lang="en-US" sz="2400" dirty="0"/>
           </a:p>
@@ -13605,7 +13605,7 @@
                 <a:ea typeface="Calibri" pitchFamily="34" charset="-122"/>
                 <a:cs typeface="Calibri" pitchFamily="34" charset="-120"/>
               </a:rPr>
-              <a:t>Prüfe: Passt jedes Datum zum Ereignis?</a:t>
+              <a:t>Prüfe: Passt jedes Ereignis zum Datum?</a:t>
             </a:r>
             <a:endParaRPr lang="en-US" sz="2400" dirty="0"/>
           </a:p>

</xml_diff>